<commit_message>
Modifed code and draft 1
</commit_message>
<xml_diff>
--- a/presentations/workflow_presentation.pptx
+++ b/presentations/workflow_presentation.pptx
@@ -17,9 +17,12 @@
     <p:sldId id="265" r:id="rId11"/>
     <p:sldId id="266" r:id="rId12"/>
     <p:sldId id="267" r:id="rId13"/>
+    <p:sldId id="268" r:id="rId14"/>
+    <p:sldId id="269" r:id="rId15"/>
+    <p:sldId id="270" r:id="rId16"/>
   </p:sldIdLst>
   <p:notesMasterIdLst>
-    <p:notesMasterId r:id="rId14"/>
+    <p:notesMasterId r:id="rId17"/>
   </p:notesMasterIdLst>
   <p:sldSz cx="12192000" cy="6858000"/>
   <p:notesSz cx="6858000" cy="12192000"/>
@@ -513,7 +516,9 @@
           <a:p>
             <a:r>
               <a:rPr lang="en-US" dirty="0"/>
-              <a:t>Presenter note: Introduce the scope and emphasize this is a full pipeline from satellite geometry to decoding KPIs.</a:t>
+              <a:t>Speech script:
+Today I will explain a compact energy-aware LR-FHSS model.
+I will focus on three things: what we model, how the equations are combined, and why each equation is justified by prior research.</a:t>
             </a:r>
             <a:endParaRPr lang="en-US" dirty="0"/>
           </a:p>
@@ -601,7 +606,11 @@
           <a:p>
             <a:r>
               <a:rPr lang="en-US" dirty="0"/>
-              <a:t>Presenter note: Mention first command for default execution and second for custom sweeps.</a:t>
+              <a:t>Speech script:
+Here we add battery realism.
+Near full SoC, charge acceptance tapers, so we cannot absorb all surplus.
+That is why positive surplus does not always mean large positive net charging.
+Net battery power is charge minus discharge branch.</a:t>
             </a:r>
             <a:endParaRPr lang="en-US" dirty="0"/>
           </a:p>
@@ -689,7 +698,11 @@
           <a:p>
             <a:r>
               <a:rPr lang="en-US" dirty="0"/>
-              <a:t>Presenter note: Position these as actionable next steps for stronger experimental confidence.</a:t>
+              <a:t>Speech script:
+Battery is updated from energy, not from ad-hoc percentages.
+We integrate net power over the step duration.
+Charge and discharge efficiencies are handled separately.
+Finally, SoC is clipped to physical limits.</a:t>
             </a:r>
             <a:endParaRPr lang="en-US" dirty="0"/>
           </a:p>
@@ -777,7 +790,11 @@
           <a:p>
             <a:r>
               <a:rPr lang="en-US" dirty="0"/>
-              <a:t>Presenter note: End by tying technical findings to practical optimization direction.</a:t>
+              <a:t>Speech script:
+This is the full recurrence in one line.
+Each block feeds the next block.
+The key point is feedback: battery state affects mode, and mode affects future battery state through power.
+In the current implementation, this recurrence is applied as a one-step scenario update, not as a multi-step time trajectory across the sweep.</a:t>
             </a:r>
             <a:endParaRPr lang="en-US" dirty="0"/>
           </a:p>
@@ -819,6 +836,278 @@
 </p:notes>
 </file>
 
+<file path=ppt/notesSlides/notesSlide13.xml><?xml version="1.0" encoding="utf-8"?>
+<p:notes xmlns:a="http://schemas.openxmlformats.org/drawingml/2006/main" xmlns:r="http://schemas.openxmlformats.org/officeDocument/2006/relationships" xmlns:p="http://schemas.openxmlformats.org/presentationml/2006/main">
+  <p:cSld>
+    <p:spTree>
+      <p:nvGrpSpPr>
+        <p:cNvPr id="1" name=""/>
+        <p:cNvGrpSpPr/>
+        <p:nvPr/>
+      </p:nvGrpSpPr>
+      <p:grpSpPr>
+        <a:xfrm>
+          <a:off x="0" y="0"/>
+          <a:ext cx="0" cy="0"/>
+          <a:chOff x="0" y="0"/>
+          <a:chExt cx="0" cy="0"/>
+        </a:xfrm>
+      </p:grpSpPr>
+      <p:sp>
+        <p:nvSpPr>
+          <p:cNvPr id="2" name="Slide Image Placeholder 1"/>
+          <p:cNvSpPr>
+            <a:spLocks noGrp="1" noRot="1" noChangeAspect="1"/>
+          </p:cNvSpPr>
+          <p:nvPr>
+            <p:ph type="sldImg"/>
+          </p:nvPr>
+        </p:nvSpPr>
+        <p:spPr/>
+      </p:sp>
+      <p:sp>
+        <p:nvSpPr>
+          <p:cNvPr id="3" name="Notes Placeholder 2"/>
+          <p:cNvSpPr>
+            <a:spLocks noGrp="1"/>
+          </p:cNvSpPr>
+          <p:nvPr>
+            <p:ph type="body" idx="1"/>
+          </p:nvPr>
+        </p:nvSpPr>
+        <p:spPr/>
+        <p:txBody>
+          <a:bodyPr/>
+          <a:lstStyle/>
+          <a:p>
+            <a:r>
+              <a:rPr lang="en-US" dirty="0"/>
+              <a:t>Speech script:
+This is a first-order model.
+It is strong for design exploration and policy comparison.
+It is not a replacement for electrochemical battery simulators or detailed thermal-orbital tools.</a:t>
+            </a:r>
+            <a:endParaRPr lang="en-US" dirty="0"/>
+          </a:p>
+        </p:txBody>
+      </p:sp>
+      <p:sp>
+        <p:nvSpPr>
+          <p:cNvPr id="4" name="Slide Number Placeholder 3"/>
+          <p:cNvSpPr>
+            <a:spLocks noGrp="1"/>
+          </p:cNvSpPr>
+          <p:nvPr>
+            <p:ph type="sldNum" sz="quarter" idx="10"/>
+          </p:nvPr>
+        </p:nvSpPr>
+        <p:spPr/>
+        <p:txBody>
+          <a:bodyPr/>
+          <a:lstStyle/>
+          <a:p>
+            <a:fld id="{F7021451-1387-4CA6-816F-3879F97B5CBC}" type="slidenum">
+              <a:rPr lang="en-US"/>
+              <a:t>13</a:t>
+            </a:fld>
+            <a:endParaRPr lang="en-US"/>
+          </a:p>
+        </p:txBody>
+      </p:sp>
+    </p:spTree>
+    <p:extLst>
+      <p:ext uri="{BB962C8B-B14F-4D97-AF65-F5344CB8AC3E}">
+        <p14:creationId xmlns:p14="http://schemas.microsoft.com/office/powerpoint/2010/main" val="1024086991"/>
+      </p:ext>
+    </p:extLst>
+  </p:cSld>
+  <p:clrMapOvr>
+    <a:masterClrMapping/>
+  </p:clrMapOvr>
+</p:notes>
+</file>
+
+<file path=ppt/notesSlides/notesSlide14.xml><?xml version="1.0" encoding="utf-8"?>
+<p:notes xmlns:a="http://schemas.openxmlformats.org/drawingml/2006/main" xmlns:r="http://schemas.openxmlformats.org/officeDocument/2006/relationships" xmlns:p="http://schemas.openxmlformats.org/presentationml/2006/main">
+  <p:cSld>
+    <p:spTree>
+      <p:nvGrpSpPr>
+        <p:cNvPr id="1" name=""/>
+        <p:cNvGrpSpPr/>
+        <p:nvPr/>
+      </p:nvGrpSpPr>
+      <p:grpSpPr>
+        <a:xfrm>
+          <a:off x="0" y="0"/>
+          <a:ext cx="0" cy="0"/>
+          <a:chOff x="0" y="0"/>
+          <a:chExt cx="0" cy="0"/>
+        </a:xfrm>
+      </p:grpSpPr>
+      <p:sp>
+        <p:nvSpPr>
+          <p:cNvPr id="2" name="Slide Image Placeholder 1"/>
+          <p:cNvSpPr>
+            <a:spLocks noGrp="1" noRot="1" noChangeAspect="1"/>
+          </p:cNvSpPr>
+          <p:nvPr>
+            <p:ph type="sldImg"/>
+          </p:nvPr>
+        </p:nvSpPr>
+        <p:spPr/>
+      </p:sp>
+      <p:sp>
+        <p:nvSpPr>
+          <p:cNvPr id="3" name="Notes Placeholder 2"/>
+          <p:cNvSpPr>
+            <a:spLocks noGrp="1"/>
+          </p:cNvSpPr>
+          <p:nvPr>
+            <p:ph type="body" idx="1"/>
+          </p:nvPr>
+        </p:nvSpPr>
+        <p:spPr/>
+        <p:txBody>
+          <a:bodyPr/>
+          <a:lstStyle/>
+          <a:p>
+            <a:r>
+              <a:rPr lang="en-US" dirty="0"/>
+              <a:t>Speech script:
+These references justify the foundations:
+SoC integration, battery behavior, and utilization-power relationship.
+We use adapted forms of these ideas for LR-FHSS receiver operation; not every equation is copied directly.</a:t>
+            </a:r>
+            <a:endParaRPr lang="en-US" dirty="0"/>
+          </a:p>
+        </p:txBody>
+      </p:sp>
+      <p:sp>
+        <p:nvSpPr>
+          <p:cNvPr id="4" name="Slide Number Placeholder 3"/>
+          <p:cNvSpPr>
+            <a:spLocks noGrp="1"/>
+          </p:cNvSpPr>
+          <p:nvPr>
+            <p:ph type="sldNum" sz="quarter" idx="10"/>
+          </p:nvPr>
+        </p:nvSpPr>
+        <p:spPr/>
+        <p:txBody>
+          <a:bodyPr/>
+          <a:lstStyle/>
+          <a:p>
+            <a:fld id="{F7021451-1387-4CA6-816F-3879F97B5CBC}" type="slidenum">
+              <a:rPr lang="en-US"/>
+              <a:t>14</a:t>
+            </a:fld>
+            <a:endParaRPr lang="en-US"/>
+          </a:p>
+        </p:txBody>
+      </p:sp>
+    </p:spTree>
+    <p:extLst>
+      <p:ext uri="{BB962C8B-B14F-4D97-AF65-F5344CB8AC3E}">
+        <p14:creationId xmlns:p14="http://schemas.microsoft.com/office/powerpoint/2010/main" val="1024086991"/>
+      </p:ext>
+    </p:extLst>
+  </p:cSld>
+  <p:clrMapOvr>
+    <a:masterClrMapping/>
+  </p:clrMapOvr>
+</p:notes>
+</file>
+
+<file path=ppt/notesSlides/notesSlide15.xml><?xml version="1.0" encoding="utf-8"?>
+<p:notes xmlns:a="http://schemas.openxmlformats.org/drawingml/2006/main" xmlns:r="http://schemas.openxmlformats.org/officeDocument/2006/relationships" xmlns:p="http://schemas.openxmlformats.org/presentationml/2006/main">
+  <p:cSld>
+    <p:spTree>
+      <p:nvGrpSpPr>
+        <p:cNvPr id="1" name=""/>
+        <p:cNvGrpSpPr/>
+        <p:nvPr/>
+      </p:nvGrpSpPr>
+      <p:grpSpPr>
+        <a:xfrm>
+          <a:off x="0" y="0"/>
+          <a:ext cx="0" cy="0"/>
+          <a:chOff x="0" y="0"/>
+          <a:chExt cx="0" cy="0"/>
+        </a:xfrm>
+      </p:grpSpPr>
+      <p:sp>
+        <p:nvSpPr>
+          <p:cNvPr id="2" name="Slide Image Placeholder 1"/>
+          <p:cNvSpPr>
+            <a:spLocks noGrp="1" noRot="1" noChangeAspect="1"/>
+          </p:cNvSpPr>
+          <p:nvPr>
+            <p:ph type="sldImg"/>
+          </p:nvPr>
+        </p:nvSpPr>
+        <p:spPr/>
+      </p:sp>
+      <p:sp>
+        <p:nvSpPr>
+          <p:cNvPr id="3" name="Notes Placeholder 2"/>
+          <p:cNvSpPr>
+            <a:spLocks noGrp="1"/>
+          </p:cNvSpPr>
+          <p:nvPr>
+            <p:ph type="body" idx="1"/>
+          </p:nvPr>
+        </p:nvSpPr>
+        <p:spPr/>
+        <p:txBody>
+          <a:bodyPr/>
+          <a:lstStyle/>
+          <a:p>
+            <a:r>
+              <a:rPr lang="en-US" dirty="0"/>
+              <a:t>Speech script:
+These papers support the spacecraft EPS energy-balance simplification and the charge-taper behavior near full SoC.
+Together they justify the power-generation and battery-side parts of the model.</a:t>
+            </a:r>
+            <a:endParaRPr lang="en-US" dirty="0"/>
+          </a:p>
+        </p:txBody>
+      </p:sp>
+      <p:sp>
+        <p:nvSpPr>
+          <p:cNvPr id="4" name="Slide Number Placeholder 3"/>
+          <p:cNvSpPr>
+            <a:spLocks noGrp="1"/>
+          </p:cNvSpPr>
+          <p:nvPr>
+            <p:ph type="sldNum" sz="quarter" idx="10"/>
+          </p:nvPr>
+        </p:nvSpPr>
+        <p:spPr/>
+        <p:txBody>
+          <a:bodyPr/>
+          <a:lstStyle/>
+          <a:p>
+            <a:fld id="{F7021451-1387-4CA6-816F-3879F97B5CBC}" type="slidenum">
+              <a:rPr lang="en-US"/>
+              <a:t>15</a:t>
+            </a:fld>
+            <a:endParaRPr lang="en-US"/>
+          </a:p>
+        </p:txBody>
+      </p:sp>
+    </p:spTree>
+    <p:extLst>
+      <p:ext uri="{BB962C8B-B14F-4D97-AF65-F5344CB8AC3E}">
+        <p14:creationId xmlns:p14="http://schemas.microsoft.com/office/powerpoint/2010/main" val="1024086991"/>
+      </p:ext>
+    </p:extLst>
+  </p:cSld>
+  <p:clrMapOvr>
+    <a:masterClrMapping/>
+  </p:clrMapOvr>
+</p:notes>
+</file>
+
 <file path=ppt/notesSlides/notesSlide2.xml><?xml version="1.0" encoding="utf-8"?>
 <p:notes xmlns:a="http://schemas.openxmlformats.org/drawingml/2006/main" xmlns:r="http://schemas.openxmlformats.org/officeDocument/2006/relationships" xmlns:p="http://schemas.openxmlformats.org/presentationml/2006/main">
   <p:cSld>
@@ -865,7 +1154,11 @@
           <a:p>
             <a:r>
               <a:rPr lang="en-US" dirty="0"/>
-              <a:t>Presenter note: State that the main question is where performance breaks first under heavy load.</a:t>
+              <a:t>Speech script:
+This slide defines the system boundary.
+The communication side is node load and demodulator budget.
+The power side is solar generation and battery state.
+These four state variables are enough to drive the one-step model.</a:t>
             </a:r>
             <a:endParaRPr lang="en-US" dirty="0"/>
           </a:p>
@@ -953,7 +1246,9 @@
           <a:p>
             <a:r>
               <a:rPr lang="en-US" dirty="0"/>
-              <a:t>Presenter note: Walk through quickly and mention modularity for future extensions.</a:t>
+              <a:t>Speech script:
+This is a quick bridge from equations to code names.
+It makes implementation auditing straightforward.</a:t>
             </a:r>
             <a:endParaRPr lang="en-US" dirty="0"/>
           </a:p>
@@ -1041,7 +1336,10 @@
           <a:p>
             <a:r>
               <a:rPr lang="en-US" dirty="0"/>
-              <a:t>Presenter note: Highlight reproducibility and zero-manual setup from dependency bootstrap.</a:t>
+              <a:t>Speech script:
+If we optimize only decoding, we may choose infeasible operating points.
+If we optimize only energy, we ignore communication utility.
+So we frame a constrained objective: maximize decoding while keeping battery operation feasible.</a:t>
             </a:r>
             <a:endParaRPr lang="en-US" dirty="0"/>
           </a:p>
@@ -1129,7 +1427,11 @@
           <a:p>
             <a:r>
               <a:rPr lang="en-US" dirty="0"/>
-              <a:t>Presenter note: Explain that this is a simple policy baseline and can be replaced by smarter adaptive policies.</a:t>
+              <a:t>Speech script:
+First we choose operating mode.
+Sleep is enforced when battery is low, no visibility, no traffic, or no allocated demods.
+Idle and busy separate conservative and aggressive operation, including a low-load idle branch.
+This is a control policy, not a physical law.</a:t>
             </a:r>
             <a:endParaRPr lang="en-US" dirty="0"/>
           </a:p>
@@ -1217,7 +1519,11 @@
           <a:p>
             <a:r>
               <a:rPr lang="en-US" dirty="0"/>
-              <a:t>Presenter note: Emphasize this loop is the experiment matrix: nodes x demods.</a:t>
+              <a:t>Speech script:
+Mode directly determines active decoding hardware.
+In sleep we force zero demodulators.
+In active modes we allocate the requested demodulators.
+This creates the coupling from policy to communication capacity.</a:t>
             </a:r>
             <a:endParaRPr lang="en-US" dirty="0"/>
           </a:p>
@@ -1305,7 +1611,11 @@
           <a:p>
             <a:r>
               <a:rPr lang="en-US" dirty="0"/>
-              <a:t>Presenter note: Mention that CSV supports post-analysis while PNG enables immediate reporting.</a:t>
+              <a:t>Speech script:
+Now we map demand to utilization.
+The ratio T over kD tells us how loaded the demodulator pool is.
+Clipping at 1 means saturation.
+This variable drives both power consumption and performance stress.</a:t>
             </a:r>
             <a:endParaRPr lang="en-US" dirty="0"/>
           </a:p>
@@ -1393,7 +1703,11 @@
           <a:p>
             <a:r>
               <a:rPr lang="en-US" dirty="0"/>
-              <a:t>Presenter note: Use this slide to confirm coverage and reassure audience the sweep is broad.</a:t>
+              <a:t>Speech script:
+Consumption has a baseline plus an active demodulator term.
+The active term is affine in utilization.
+Busy mode uses larger coefficients than idle mode.
+This follows energy-proportional modeling ideas adapted to demodulators.</a:t>
             </a:r>
             <a:endParaRPr lang="en-US" dirty="0"/>
           </a:p>
@@ -1481,7 +1795,11 @@
           <a:p>
             <a:r>
               <a:rPr lang="en-US" dirty="0"/>
-              <a:t>Presenter note: Stress that collision behavior, not only demod budget, dominates in heavy-load regimes.</a:t>
+              <a:t>Speech script:
+Generation is modeled from visibility and solar efficiency.
+Subtracting load gives surplus power.
+Positive surplus means charging is possible.
+Negative surplus means battery must discharge.</a:t>
             </a:r>
             <a:endParaRPr lang="en-US" dirty="0"/>
           </a:p>
@@ -1950,6 +2268,123 @@
 <file path=ppt/slides/slide12.xml><?xml version="1.0" encoding="utf-8"?>
 <p:sld xmlns:a="http://schemas.openxmlformats.org/drawingml/2006/main" xmlns:r="http://schemas.openxmlformats.org/officeDocument/2006/relationships" xmlns:p="http://schemas.openxmlformats.org/presentationml/2006/main">
   <p:cSld name="Slide 12">
+    <p:bg>
+      <p:bgPr>
+        <a:blipFill dpi="0" rotWithShape="1">
+          <a:blip r:embed="rId1">
+            <a:lum/>
+          </a:blip>
+          <a:srcRect/>
+          <a:stretch>
+            <a:fillRect/>
+          </a:stretch>
+        </a:blipFill>
+        <a:effectLst/>
+      </p:bgPr>
+    </p:bg>
+    <p:spTree>
+      <p:nvGrpSpPr>
+        <p:cNvPr id="1" name=""/>
+        <p:cNvGrpSpPr/>
+        <p:nvPr/>
+      </p:nvGrpSpPr>
+      <p:grpSpPr>
+        <a:xfrm>
+          <a:off x="0" y="0"/>
+          <a:ext cx="0" cy="0"/>
+          <a:chOff x="0" y="0"/>
+          <a:chExt cx="0" cy="0"/>
+        </a:xfrm>
+      </p:grpSpPr>
+    </p:spTree>
+  </p:cSld>
+  <p:clrMapOvr>
+    <a:masterClrMapping/>
+  </p:clrMapOvr>
+</p:sld>
+</file>
+
+<file path=ppt/slides/slide13.xml><?xml version="1.0" encoding="utf-8"?>
+<p:sld xmlns:a="http://schemas.openxmlformats.org/drawingml/2006/main" xmlns:r="http://schemas.openxmlformats.org/officeDocument/2006/relationships" xmlns:p="http://schemas.openxmlformats.org/presentationml/2006/main">
+  <p:cSld name="Slide 13">
+    <p:bg>
+      <p:bgPr>
+        <a:blipFill dpi="0" rotWithShape="1">
+          <a:blip r:embed="rId1">
+            <a:lum/>
+          </a:blip>
+          <a:srcRect/>
+          <a:stretch>
+            <a:fillRect/>
+          </a:stretch>
+        </a:blipFill>
+        <a:effectLst/>
+      </p:bgPr>
+    </p:bg>
+    <p:spTree>
+      <p:nvGrpSpPr>
+        <p:cNvPr id="1" name=""/>
+        <p:cNvGrpSpPr/>
+        <p:nvPr/>
+      </p:nvGrpSpPr>
+      <p:grpSpPr>
+        <a:xfrm>
+          <a:off x="0" y="0"/>
+          <a:ext cx="0" cy="0"/>
+          <a:chOff x="0" y="0"/>
+          <a:chExt cx="0" cy="0"/>
+        </a:xfrm>
+      </p:grpSpPr>
+    </p:spTree>
+  </p:cSld>
+  <p:clrMapOvr>
+    <a:masterClrMapping/>
+  </p:clrMapOvr>
+</p:sld>
+</file>
+
+<file path=ppt/slides/slide14.xml><?xml version="1.0" encoding="utf-8"?>
+<p:sld xmlns:a="http://schemas.openxmlformats.org/drawingml/2006/main" xmlns:r="http://schemas.openxmlformats.org/officeDocument/2006/relationships" xmlns:p="http://schemas.openxmlformats.org/presentationml/2006/main">
+  <p:cSld name="Slide 14">
+    <p:bg>
+      <p:bgPr>
+        <a:blipFill dpi="0" rotWithShape="1">
+          <a:blip r:embed="rId1">
+            <a:lum/>
+          </a:blip>
+          <a:srcRect/>
+          <a:stretch>
+            <a:fillRect/>
+          </a:stretch>
+        </a:blipFill>
+        <a:effectLst/>
+      </p:bgPr>
+    </p:bg>
+    <p:spTree>
+      <p:nvGrpSpPr>
+        <p:cNvPr id="1" name=""/>
+        <p:cNvGrpSpPr/>
+        <p:nvPr/>
+      </p:nvGrpSpPr>
+      <p:grpSpPr>
+        <a:xfrm>
+          <a:off x="0" y="0"/>
+          <a:ext cx="0" cy="0"/>
+          <a:chOff x="0" y="0"/>
+          <a:chExt cx="0" cy="0"/>
+        </a:xfrm>
+      </p:grpSpPr>
+    </p:spTree>
+  </p:cSld>
+  <p:clrMapOvr>
+    <a:masterClrMapping/>
+  </p:clrMapOvr>
+</p:sld>
+</file>
+
+<file path=ppt/slides/slide15.xml><?xml version="1.0" encoding="utf-8"?>
+<p:sld xmlns:a="http://schemas.openxmlformats.org/drawingml/2006/main" xmlns:r="http://schemas.openxmlformats.org/officeDocument/2006/relationships" xmlns:p="http://schemas.openxmlformats.org/presentationml/2006/main">
+  <p:cSld name="Slide 15">
     <p:bg>
       <p:bgPr>
         <a:blipFill dpi="0" rotWithShape="1">

</xml_diff>